<commit_message>
Add market sources to deck and Initio profile answers
Co-Authored-By: Claude Opus 5.5 <noreply@anthropic.com>
Claude-Session: https://claude.ai/code/session_01Kb7k1mwMTUZRFKd9bWckpj
</commit_message>
<xml_diff>
--- a/pitch-deck/Cedarworks-Apps-Pitch-Deck.pptx
+++ b/pitch-deck/Cedarworks-Apps-Pitch-Deck.pptx
@@ -17884,8 +17884,8 @@
         </p:nvSpPr>
         <p:spPr>
           <a:xfrm>
-            <a:off x="457200" y="1463040"/>
-            <a:ext cx="3108960" cy="3108960"/>
+            <a:off x="548640" y="1417320"/>
+            <a:ext cx="2834640" cy="2834640"/>
           </a:xfrm>
           <a:prstGeom prst="ellipse">
             <a:avLst/>
@@ -17909,8 +17909,8 @@
         </p:nvSpPr>
         <p:spPr>
           <a:xfrm>
-            <a:off x="1051560" y="2286000"/>
-            <a:ext cx="1920240" cy="1920240"/>
+            <a:off x="1074420" y="2331720"/>
+            <a:ext cx="1783080" cy="1783080"/>
           </a:xfrm>
           <a:prstGeom prst="ellipse">
             <a:avLst/>
@@ -17934,8 +17934,8 @@
         </p:nvSpPr>
         <p:spPr>
           <a:xfrm>
-            <a:off x="1554480" y="3246120"/>
-            <a:ext cx="914400" cy="914400"/>
+            <a:off x="1531620" y="3154680"/>
+            <a:ext cx="868680" cy="868680"/>
           </a:xfrm>
           <a:prstGeom prst="ellipse">
             <a:avLst/>
@@ -17959,8 +17959,8 @@
         </p:nvSpPr>
         <p:spPr>
           <a:xfrm>
-            <a:off x="457200" y="1691640"/>
-            <a:ext cx="3108960" cy="274320"/>
+            <a:off x="548640" y="1645920"/>
+            <a:ext cx="2834640" cy="274320"/>
           </a:xfrm>
           <a:prstGeom prst="rect">
             <a:avLst/>
@@ -17998,8 +17998,8 @@
         </p:nvSpPr>
         <p:spPr>
           <a:xfrm>
-            <a:off x="1051560" y="2560320"/>
-            <a:ext cx="1920240" cy="274320"/>
+            <a:off x="1074420" y="2560320"/>
+            <a:ext cx="1783080" cy="274320"/>
           </a:xfrm>
           <a:prstGeom prst="rect">
             <a:avLst/>
@@ -18037,8 +18037,8 @@
         </p:nvSpPr>
         <p:spPr>
           <a:xfrm>
-            <a:off x="1554480" y="3429000"/>
-            <a:ext cx="914400" cy="548640"/>
+            <a:off x="1531620" y="3319272"/>
+            <a:ext cx="868680" cy="548640"/>
           </a:xfrm>
           <a:prstGeom prst="rect">
             <a:avLst/>
@@ -18093,7 +18093,7 @@
         </p:nvSpPr>
         <p:spPr>
           <a:xfrm>
-            <a:off x="3931920" y="1463040"/>
+            <a:off x="3931920" y="1417320"/>
             <a:ext cx="4754880" cy="246888"/>
           </a:xfrm>
           <a:prstGeom prst="rect">
@@ -18132,7 +18132,7 @@
         </p:nvSpPr>
         <p:spPr>
           <a:xfrm>
-            <a:off x="3931920" y="1719072"/>
+            <a:off x="3931920" y="1673352"/>
             <a:ext cx="4754880" cy="475488"/>
           </a:xfrm>
           <a:prstGeom prst="rect">
@@ -18171,7 +18171,7 @@
         </p:nvSpPr>
         <p:spPr>
           <a:xfrm>
-            <a:off x="3931920" y="2240280"/>
+            <a:off x="3931920" y="2148840"/>
             <a:ext cx="4754880" cy="246888"/>
           </a:xfrm>
           <a:prstGeom prst="rect">
@@ -18210,7 +18210,7 @@
         </p:nvSpPr>
         <p:spPr>
           <a:xfrm>
-            <a:off x="3931920" y="2496312"/>
+            <a:off x="3931920" y="2404872"/>
             <a:ext cx="4754880" cy="475488"/>
           </a:xfrm>
           <a:prstGeom prst="rect">
@@ -18249,7 +18249,7 @@
         </p:nvSpPr>
         <p:spPr>
           <a:xfrm>
-            <a:off x="3931920" y="3017520"/>
+            <a:off x="3931920" y="2880360"/>
             <a:ext cx="4754880" cy="246888"/>
           </a:xfrm>
           <a:prstGeom prst="rect">
@@ -18288,7 +18288,7 @@
         </p:nvSpPr>
         <p:spPr>
           <a:xfrm>
-            <a:off x="3931920" y="3273552"/>
+            <a:off x="3931920" y="3136392"/>
             <a:ext cx="4754880" cy="475488"/>
           </a:xfrm>
           <a:prstGeom prst="rect">
@@ -18327,7 +18327,7 @@
         </p:nvSpPr>
         <p:spPr>
           <a:xfrm>
-            <a:off x="3931920" y="3794760"/>
+            <a:off x="3931920" y="3611880"/>
             <a:ext cx="4754880" cy="246888"/>
           </a:xfrm>
           <a:prstGeom prst="rect">
@@ -18366,7 +18366,7 @@
         </p:nvSpPr>
         <p:spPr>
           <a:xfrm>
-            <a:off x="3931920" y="4050792"/>
+            <a:off x="3931920" y="3867912"/>
             <a:ext cx="4754880" cy="475488"/>
           </a:xfrm>
           <a:prstGeom prst="rect">
@@ -18400,6 +18400,45 @@
       <p:sp>
         <p:nvSpPr>
           <p:cNvPr id="18" name="Text 16"/>
+          <p:cNvSpPr txBox="1"/>
+          <p:nvPr/>
+        </p:nvSpPr>
+        <p:spPr>
+          <a:xfrm>
+            <a:off x="457200" y="4389120"/>
+            <a:ext cx="8229600" cy="329184"/>
+          </a:xfrm>
+          <a:prstGeom prst="rect">
+            <a:avLst/>
+          </a:prstGeom>
+          <a:noFill/>
+          <a:ln/>
+        </p:spPr>
+        <p:txBody>
+          <a:bodyPr wrap="square" lIns="0" tIns="0" rIns="0" bIns="0" rtlCol="0" anchor="t"/>
+          <a:lstStyle/>
+          <a:p>
+            <a:pPr indent="0" marL="0">
+              <a:buNone/>
+            </a:pPr>
+            <a:r>
+              <a:rPr lang="en-US" sz="850" i="1" dirty="0">
+                <a:solidFill>
+                  <a:srgbClr val="5C6B61"/>
+                </a:solidFill>
+                <a:latin typeface="Calibri" pitchFamily="34" charset="0"/>
+                <a:ea typeface="Calibri" pitchFamily="34" charset="-122"/>
+                <a:cs typeface="Calibri" pitchFamily="34" charset="-120"/>
+              </a:rPr>
+              <a:t>Sources: Hartford Institute for Religion Research &amp; U.S. Religion Census (congregations); U.S. Bureau of Labor Statistics, Occupational Employment &amp; Wage Statistics (sales representatives, wholesale &amp; manufacturing). Prices: current PastorAI and Ready Room plans.</a:t>
+            </a:r>
+            <a:endParaRPr lang="en-US" sz="850" dirty="0"/>
+          </a:p>
+        </p:txBody>
+      </p:sp>
+      <p:sp>
+        <p:nvSpPr>
+          <p:cNvPr id="19" name="Text 17"/>
           <p:cNvSpPr txBox="1"/>
           <p:nvPr/>
         </p:nvSpPr>
@@ -18438,7 +18477,7 @@
       </p:sp>
       <p:sp>
         <p:nvSpPr>
-          <p:cNvPr id="19" name="Text 17"/>
+          <p:cNvPr id="20" name="Text 18"/>
           <p:cNvSpPr txBox="1"/>
           <p:nvPr/>
         </p:nvSpPr>

</xml_diff>

<commit_message>
Tighten deck wording to match Initio's next-action report
Label pain points, what we offer, revenue streams, and direct vs
indirect competitors; state MRR and team size explicitly. Add a
competitive landscape answer to the profile answers.

Co-Authored-By: Claude Opus 5.5 <noreply@anthropic.com>
Claude-Session: https://claude.ai/code/session_01Kb7k1mwMTUZRFKd9bWckpj
</commit_message>
<xml_diff>
--- a/pitch-deck/Cedarworks-Apps-Pitch-Deck.pptx
+++ b/pitch-deck/Cedarworks-Apps-Pitch-Deck.pptx
@@ -3266,7 +3266,7 @@
                 <a:ea typeface="Calibri" pitchFamily="34" charset="-122"/>
                 <a:cs typeface="Calibri" pitchFamily="34" charset="-120"/>
               </a:rPr>
-              <a:t>Business Model</a:t>
+              <a:t>Business Model  ·  Revenue streams &amp; unit economics</a:t>
             </a:r>
             <a:endParaRPr lang="en-US" sz="1100" dirty="0"/>
           </a:p>
@@ -4992,13 +4992,52 @@
       </p:graphicFrame>
       <p:sp>
         <p:nvSpPr>
-          <p:cNvPr id="5" name="Shape 2"/>
+          <p:cNvPr id="5" name="Text 2"/>
+          <p:cNvSpPr txBox="1"/>
+          <p:nvPr/>
+        </p:nvSpPr>
+        <p:spPr>
+          <a:xfrm>
+            <a:off x="5669280" y="1463040"/>
+            <a:ext cx="3017520" cy="237744"/>
+          </a:xfrm>
+          <a:prstGeom prst="rect">
+            <a:avLst/>
+          </a:prstGeom>
+          <a:noFill/>
+          <a:ln/>
+        </p:spPr>
+        <p:txBody>
+          <a:bodyPr wrap="square" lIns="0" tIns="0" rIns="0" bIns="0" rtlCol="0" anchor="t"/>
+          <a:lstStyle/>
+          <a:p>
+            <a:pPr indent="0" marL="0">
+              <a:buNone/>
+            </a:pPr>
+            <a:r>
+              <a:rPr lang="en-US" sz="1100" b="1" dirty="0">
+                <a:solidFill>
+                  <a:srgbClr val="D98B3C"/>
+                </a:solidFill>
+                <a:latin typeface="Calibri" pitchFamily="34" charset="0"/>
+                <a:ea typeface="Calibri" pitchFamily="34" charset="-122"/>
+                <a:cs typeface="Calibri" pitchFamily="34" charset="-120"/>
+              </a:rPr>
+              <a:t>Revenue streams</a:t>
+            </a:r>
+            <a:endParaRPr lang="en-US" sz="1100" dirty="0"/>
+          </a:p>
+        </p:txBody>
+      </p:sp>
+      <p:sp>
+        <p:nvSpPr>
+          <p:cNvPr id="6" name="Shape 3"/>
           <p:cNvSpPr/>
           <p:nvPr/>
         </p:nvSpPr>
         <p:spPr>
           <a:xfrm>
-            <a:off x="5669280" y="1463040"/>
+            <a:off x="5669280" y="1783080"/>
             <a:ext cx="457200" cy="457200"/>
           </a:xfrm>
           <a:prstGeom prst="ellipse">
@@ -5017,7 +5056,7 @@
       </p:sp>
       <p:pic>
         <p:nvPicPr>
-          <p:cNvPr id="6" name="Image 0" descr="preencoded.png">    </p:cNvPr>
+          <p:cNvPr id="7" name="Image 0" descr="preencoded.png">    </p:cNvPr>
           <p:cNvPicPr>
             <a:picLocks noChangeAspect="1"/>
           </p:cNvPicPr>
@@ -5031,7 +5070,7 @@
         </p:blipFill>
         <p:spPr>
           <a:xfrm>
-            <a:off x="5788152" y="1581912"/>
+            <a:off x="5788152" y="1901952"/>
             <a:ext cx="219456" cy="219456"/>
           </a:xfrm>
           <a:prstGeom prst="rect">
@@ -5041,13 +5080,13 @@
       </p:pic>
       <p:sp>
         <p:nvSpPr>
-          <p:cNvPr id="7" name="Text 3"/>
-          <p:cNvSpPr txBox="1"/>
-          <p:nvPr/>
-        </p:nvSpPr>
-        <p:spPr>
-          <a:xfrm>
-            <a:off x="6263640" y="1463040"/>
+          <p:cNvPr id="8" name="Text 4"/>
+          <p:cNvSpPr txBox="1"/>
+          <p:nvPr/>
+        </p:nvSpPr>
+        <p:spPr>
+          <a:xfrm>
+            <a:off x="6263640" y="1783080"/>
             <a:ext cx="2423160" cy="256032"/>
           </a:xfrm>
           <a:prstGeom prst="rect">
@@ -5080,13 +5119,13 @@
       </p:sp>
       <p:sp>
         <p:nvSpPr>
-          <p:cNvPr id="8" name="Text 4"/>
-          <p:cNvSpPr txBox="1"/>
-          <p:nvPr/>
-        </p:nvSpPr>
-        <p:spPr>
-          <a:xfrm>
-            <a:off x="6263640" y="1719072"/>
+          <p:cNvPr id="9" name="Text 5"/>
+          <p:cNvSpPr txBox="1"/>
+          <p:nvPr/>
+        </p:nvSpPr>
+        <p:spPr>
+          <a:xfrm>
+            <a:off x="6263640" y="2039112"/>
             <a:ext cx="2423160" cy="548640"/>
           </a:xfrm>
           <a:prstGeom prst="rect">
@@ -5119,13 +5158,13 @@
       </p:sp>
       <p:sp>
         <p:nvSpPr>
-          <p:cNvPr id="9" name="Shape 5"/>
+          <p:cNvPr id="10" name="Shape 6"/>
           <p:cNvSpPr/>
           <p:nvPr/>
         </p:nvSpPr>
         <p:spPr>
           <a:xfrm>
-            <a:off x="5669280" y="2404872"/>
+            <a:off x="5669280" y="2651760"/>
             <a:ext cx="457200" cy="457200"/>
           </a:xfrm>
           <a:prstGeom prst="ellipse">
@@ -5144,7 +5183,7 @@
       </p:sp>
       <p:pic>
         <p:nvPicPr>
-          <p:cNvPr id="10" name="Image 1" descr="preencoded.png">    </p:cNvPr>
+          <p:cNvPr id="11" name="Image 1" descr="preencoded.png">    </p:cNvPr>
           <p:cNvPicPr>
             <a:picLocks noChangeAspect="1"/>
           </p:cNvPicPr>
@@ -5158,7 +5197,7 @@
         </p:blipFill>
         <p:spPr>
           <a:xfrm>
-            <a:off x="5788152" y="2523744"/>
+            <a:off x="5788152" y="2770632"/>
             <a:ext cx="219456" cy="219456"/>
           </a:xfrm>
           <a:prstGeom prst="rect">
@@ -5168,13 +5207,13 @@
       </p:pic>
       <p:sp>
         <p:nvSpPr>
-          <p:cNvPr id="11" name="Text 6"/>
-          <p:cNvSpPr txBox="1"/>
-          <p:nvPr/>
-        </p:nvSpPr>
-        <p:spPr>
-          <a:xfrm>
-            <a:off x="6263640" y="2404872"/>
+          <p:cNvPr id="12" name="Text 7"/>
+          <p:cNvSpPr txBox="1"/>
+          <p:nvPr/>
+        </p:nvSpPr>
+        <p:spPr>
+          <a:xfrm>
+            <a:off x="6263640" y="2651760"/>
             <a:ext cx="2423160" cy="256032"/>
           </a:xfrm>
           <a:prstGeom prst="rect">
@@ -5207,13 +5246,13 @@
       </p:sp>
       <p:sp>
         <p:nvSpPr>
-          <p:cNvPr id="12" name="Text 7"/>
-          <p:cNvSpPr txBox="1"/>
-          <p:nvPr/>
-        </p:nvSpPr>
-        <p:spPr>
-          <a:xfrm>
-            <a:off x="6263640" y="2660904"/>
+          <p:cNvPr id="13" name="Text 8"/>
+          <p:cNvSpPr txBox="1"/>
+          <p:nvPr/>
+        </p:nvSpPr>
+        <p:spPr>
+          <a:xfrm>
+            <a:off x="6263640" y="2907792"/>
             <a:ext cx="2423160" cy="548640"/>
           </a:xfrm>
           <a:prstGeom prst="rect">
@@ -5246,13 +5285,13 @@
       </p:sp>
       <p:sp>
         <p:nvSpPr>
-          <p:cNvPr id="13" name="Shape 8"/>
+          <p:cNvPr id="14" name="Shape 9"/>
           <p:cNvSpPr/>
           <p:nvPr/>
         </p:nvSpPr>
         <p:spPr>
           <a:xfrm>
-            <a:off x="5669280" y="3346704"/>
+            <a:off x="5669280" y="3520440"/>
             <a:ext cx="457200" cy="457200"/>
           </a:xfrm>
           <a:prstGeom prst="ellipse">
@@ -5271,7 +5310,7 @@
       </p:sp>
       <p:pic>
         <p:nvPicPr>
-          <p:cNvPr id="14" name="Image 2" descr="preencoded.png">    </p:cNvPr>
+          <p:cNvPr id="15" name="Image 2" descr="preencoded.png">    </p:cNvPr>
           <p:cNvPicPr>
             <a:picLocks noChangeAspect="1"/>
           </p:cNvPicPr>
@@ -5285,7 +5324,7 @@
         </p:blipFill>
         <p:spPr>
           <a:xfrm>
-            <a:off x="5788152" y="3465576"/>
+            <a:off x="5788152" y="3639312"/>
             <a:ext cx="219456" cy="219456"/>
           </a:xfrm>
           <a:prstGeom prst="rect">
@@ -5295,13 +5334,13 @@
       </p:pic>
       <p:sp>
         <p:nvSpPr>
-          <p:cNvPr id="15" name="Text 9"/>
-          <p:cNvSpPr txBox="1"/>
-          <p:nvPr/>
-        </p:nvSpPr>
-        <p:spPr>
-          <a:xfrm>
-            <a:off x="6263640" y="3346704"/>
+          <p:cNvPr id="16" name="Text 10"/>
+          <p:cNvSpPr txBox="1"/>
+          <p:nvPr/>
+        </p:nvSpPr>
+        <p:spPr>
+          <a:xfrm>
+            <a:off x="6263640" y="3520440"/>
             <a:ext cx="2423160" cy="256032"/>
           </a:xfrm>
           <a:prstGeom prst="rect">
@@ -5334,13 +5373,13 @@
       </p:sp>
       <p:sp>
         <p:nvSpPr>
-          <p:cNvPr id="16" name="Text 10"/>
-          <p:cNvSpPr txBox="1"/>
-          <p:nvPr/>
-        </p:nvSpPr>
-        <p:spPr>
-          <a:xfrm>
-            <a:off x="6263640" y="3602736"/>
+          <p:cNvPr id="17" name="Text 11"/>
+          <p:cNvSpPr txBox="1"/>
+          <p:nvPr/>
+        </p:nvSpPr>
+        <p:spPr>
+          <a:xfrm>
+            <a:off x="6263640" y="3776472"/>
             <a:ext cx="2423160" cy="548640"/>
           </a:xfrm>
           <a:prstGeom prst="rect">
@@ -5373,7 +5412,7 @@
       </p:sp>
       <p:sp>
         <p:nvSpPr>
-          <p:cNvPr id="17" name="Text 11"/>
+          <p:cNvPr id="18" name="Text 12"/>
           <p:cNvSpPr txBox="1"/>
           <p:nvPr/>
         </p:nvSpPr>
@@ -5412,7 +5451,7 @@
       </p:sp>
       <p:sp>
         <p:nvSpPr>
-          <p:cNvPr id="18" name="Text 12"/>
+          <p:cNvPr id="19" name="Text 13"/>
           <p:cNvSpPr txBox="1"/>
           <p:nvPr/>
         </p:nvSpPr>
@@ -5451,7 +5490,7 @@
       </p:sp>
       <p:sp>
         <p:nvSpPr>
-          <p:cNvPr id="19" name="Text 13"/>
+          <p:cNvPr id="20" name="Text 14"/>
           <p:cNvSpPr txBox="1"/>
           <p:nvPr/>
         </p:nvSpPr>
@@ -6197,7 +6236,7 @@
                 <a:ea typeface="Calibri" pitchFamily="34" charset="-122"/>
                 <a:cs typeface="Calibri" pitchFamily="34" charset="-120"/>
               </a:rPr>
-              <a:t>Competitive Landscape</a:t>
+              <a:t>Competitive Landscape  ·  Direct &amp; indirect competitors</a:t>
             </a:r>
             <a:endParaRPr lang="en-US" sz="1100" dirty="0"/>
           </a:p>
@@ -6271,7 +6310,7 @@
                 <a:gridCol w="1691640"/>
                 <a:gridCol w="1234440"/>
               </a:tblGrid>
-              <a:tr h="548640">
+              <a:tr h="658368">
                 <a:tc>
                   <a:txBody>
                     <a:bodyPr/>
@@ -6346,7 +6385,7 @@
                           <a:ea typeface="Calibri" pitchFamily="34" charset="-122"/>
                           <a:cs typeface="Calibri" pitchFamily="34" charset="-120"/>
                         </a:rPr>
-                        <a:t>Generic AI chat (e.g. ChatGPT)</a:t>
+                        <a:t>Indirect: generic AI chat (e.g. ChatGPT)</a:t>
                       </a:r>
                       <a:endParaRPr lang="en-US" sz="1000" dirty="0">
                         <a:latin typeface="Calibri" charset="0"/>
@@ -6414,7 +6453,7 @@
                           <a:ea typeface="Calibri" pitchFamily="34" charset="-122"/>
                           <a:cs typeface="Calibri" pitchFamily="34" charset="-120"/>
                         </a:rPr>
-                        <a:t>Ministry software (e.g. Logos, Pulpit AI)</a:t>
+                        <a:t>Direct: ministry software (e.g. Logos, Pulpit AI)</a:t>
                       </a:r>
                       <a:endParaRPr lang="en-US" sz="1000" dirty="0">
                         <a:latin typeface="Calibri" charset="0"/>
@@ -6482,7 +6521,7 @@
                           <a:ea typeface="Calibri" pitchFamily="34" charset="-122"/>
                           <a:cs typeface="Calibri" pitchFamily="34" charset="-120"/>
                         </a:rPr>
-                        <a:t>Sales role-play (e.g. Second Nature, Hyperbound)</a:t>
+                        <a:t>Direct: sales role-play (e.g. Second Nature, Hyperbound)</a:t>
                       </a:r>
                       <a:endParaRPr lang="en-US" sz="1000" dirty="0">
                         <a:latin typeface="Calibri" charset="0"/>
@@ -6602,7 +6641,7 @@
                   </a:tcPr>
                 </a:tc>
               </a:tr>
-              <a:tr h="384048">
+              <a:tr h="365760">
                 <a:tc>
                   <a:txBody>
                     <a:bodyPr/>
@@ -6944,7 +6983,7 @@
                   </a:tcPr>
                 </a:tc>
               </a:tr>
-              <a:tr h="384048">
+              <a:tr h="365760">
                 <a:tc>
                   <a:txBody>
                     <a:bodyPr/>
@@ -7286,7 +7325,7 @@
                   </a:tcPr>
                 </a:tc>
               </a:tr>
-              <a:tr h="384048">
+              <a:tr h="365760">
                 <a:tc>
                   <a:txBody>
                     <a:bodyPr/>
@@ -7628,7 +7667,7 @@
                   </a:tcPr>
                 </a:tc>
               </a:tr>
-              <a:tr h="384048">
+              <a:tr h="365760">
                 <a:tc>
                   <a:txBody>
                     <a:bodyPr/>
@@ -7970,7 +8009,7 @@
                   </a:tcPr>
                 </a:tc>
               </a:tr>
-              <a:tr h="384048">
+              <a:tr h="365760">
                 <a:tc>
                   <a:txBody>
                     <a:bodyPr/>
@@ -11902,7 +11941,7 @@
                 <a:ea typeface="Calibri" pitchFamily="34" charset="-122"/>
                 <a:cs typeface="Calibri" pitchFamily="34" charset="-120"/>
               </a:rPr>
-              <a:t>Both apps live on iOS, Android and web; ~30 trial members; pre-revenue, launched in 2026.</a:t>
+              <a:t>Both apps live on iOS, Android and web; ~30 trial users; $0 MRR (pre-revenue); team of 1.</a:t>
             </a:r>
             <a:endParaRPr lang="en-US" sz="1050" dirty="0"/>
           </a:p>
@@ -12238,7 +12277,7 @@
                 <a:ea typeface="Calibri" pitchFamily="34" charset="-122"/>
                 <a:cs typeface="Calibri" pitchFamily="34" charset="-120"/>
               </a:rPr>
-              <a:t>Cheaper and more focused than enterprise tools, more useful than generic chatbots.</a:t>
+              <a:t>Direct: ministry software, sales role-play platforms. Indirect: ChatGPT. We win on focus and price.</a:t>
             </a:r>
             <a:endParaRPr lang="en-US" sz="1050" dirty="0"/>
           </a:p>
@@ -12611,7 +12650,7 @@
                 <a:ea typeface="Calibri" pitchFamily="34" charset="-122"/>
                 <a:cs typeface="Calibri" pitchFamily="34" charset="-120"/>
               </a:rPr>
-              <a:t>Problem Statement</a:t>
+              <a:t>Problem Statement  ·  Customer pain points</a:t>
             </a:r>
             <a:endParaRPr lang="en-US" sz="1100" dirty="0"/>
           </a:p>
@@ -13260,7 +13299,7 @@
                 <a:ea typeface="Calibri" pitchFamily="34" charset="-122"/>
                 <a:cs typeface="Calibri" pitchFamily="34" charset="-120"/>
               </a:rPr>
-              <a:t>Solution &amp; Product</a:t>
+              <a:t>Solution &amp; Product  ·  What Cedarworks offers</a:t>
             </a:r>
             <a:endParaRPr lang="en-US" sz="1100" dirty="0"/>
           </a:p>
@@ -17019,7 +17058,7 @@
                 <a:ea typeface="Calibri" pitchFamily="34" charset="-122"/>
                 <a:cs typeface="Calibri" pitchFamily="34" charset="-120"/>
               </a:rPr>
-              <a:t>launched in 2026; converting trials now</a:t>
+              <a:t>$0 MRR today · team of 1 · launched 2026</a:t>
             </a:r>
             <a:endParaRPr lang="en-US" sz="1100" dirty="0"/>
           </a:p>

</xml_diff>

<commit_message>
Remove unverified Barna statistic from deck and profile answers
Co-Authored-By: Claude Opus 5.5 <noreply@anthropic.com>
Claude-Session: https://claude.ai/code/session_01Kb7k1mwMTUZRFKd9bWckpj
</commit_message>
<xml_diff>
--- a/pitch-deck/Cedarworks-Apps-Pitch-Deck.pptx
+++ b/pitch-deck/Cedarworks-Apps-Pitch-Deck.pptx
@@ -2909,7 +2909,7 @@
           <a:p>
             <a:r>
               <a:rPr lang="en-US" dirty="0"/>
-              <a:t>The problem: skilled professionals spend hours every week on repeatable work that AI could speed up, but generic AI makes them do the translating. Pastors carry a week of writing and teaching prep, often alone, and burnout is high: Barna found 42% of U.S. pastors considered quitting full-time ministry in the past year. Sales reps have nowhere affordable to practice before a real call. I've seen both first-hand: my bishop's workload, and 40 years of selling.</a:t>
+              <a:t>The problem: skilled professionals spend hours every week on repeatable work that AI could speed up, but generic AI makes them do the translating. Pastors carry a week of writing and teaching prep, often alone, which leaves less time for their people. Sales reps have nowhere affordable to practice before a real call. I've seen both first-hand: my bishop's workload, and 40 years of selling.</a:t>
             </a:r>
             <a:endParaRPr lang="en-US" dirty="0"/>
           </a:p>
@@ -24108,7 +24108,7 @@
                 <a:ea typeface="Calibri" pitchFamily="34" charset="-122"/>
                 <a:cs typeface="Calibri" pitchFamily="34" charset="-120"/>
               </a:rPr>
-              <a:t>Sermons, Bible studies, devotionals, kids' lessons and social posts fill every week, often with little or no staff. 42% of U.S. pastors considered quitting full-time ministry in the past year (Barna Group, 2022).</a:t>
+              <a:t>Sermons, Bible studies, devotionals, kids' lessons and social posts fill every week, often with little or no staff. Most of it starts from a blank page, and it leaves little time for people.</a:t>
             </a:r>
             <a:endParaRPr lang="en-US" sz="1300" dirty="0"/>
           </a:p>

</xml_diff>

<commit_message>
Add cold email as the first customer-acquisition channel
Go-to-market, use of funds, roadmap and profile answers now lead with
cold-email campaigns to win paying customers quickly.

Co-Authored-By: Claude Opus 5.5 <noreply@anthropic.com>
Claude-Session: https://claude.ai/code/session_01Kb7k1mwMTUZRFKd9bWckpj
</commit_message>
<xml_diff>
--- a/pitch-deck/Cedarworks-Apps-Pitch-Deck.pptx
+++ b/pitch-deck/Cedarworks-Apps-Pitch-Deck.pptx
@@ -410,7 +410,7 @@
               <c:strCache>
                 <c:ptCount val="6"/>
                 <c:pt idx="0">
-                  <c:v>Marketing and outreach for all apps</c:v>
+                  <c:v>Marketing: cold email, ads and outreach</c:v>
                 </c:pt>
                 <c:pt idx="1">
                   <c:v>Founder salary: 18 months full-time</c:v>
@@ -2205,7 +2205,7 @@
           <a:p>
             <a:r>
               <a:rPr lang="en-US" dirty="0"/>
-              <a:t>The biggest use of funds is winning customers. We'll run small, measured tests on each channel, then put more money into whichever channels win paying subscribers most cheaply. AppForge writes the emails, posts, ads and presentations, so marketing each app takes far less time.</a:t>
+              <a:t>Our first channel is cold email, starting immediately: targeted campaigns to pastors and church leaders for PastorAI, and to sales reps and sales managers for Ready Room. It's low-cost and fast, and AppForge's One-to-Many Emails tool writes the campaigns. The biggest use of funds is winning customers. Alongside cold email we'll run small, measured tests on each channel, then put more money into whichever channels win paying subscribers most cheaply. AppForge writes the emails, posts, ads and presentations, so marketing each app takes far less time.</a:t>
             </a:r>
             <a:endParaRPr lang="en-US" dirty="0"/>
           </a:p>
@@ -14123,7 +14123,7 @@
                 <a:ea typeface="Calibri" pitchFamily="34" charset="-122"/>
                 <a:cs typeface="Calibri" pitchFamily="34" charset="-120"/>
               </a:rPr>
-              <a:t>Facebook and YouTube ads aimed at pastors and church staff</a:t>
+              <a:t>Cold email to pastors and church leaders, starting now</a:t>
             </a:r>
             <a:endParaRPr lang="en-US" sz="1250" dirty="0"/>
           </a:p>
@@ -14144,7 +14144,7 @@
                 <a:ea typeface="Calibri" pitchFamily="34" charset="-122"/>
                 <a:cs typeface="Calibri" pitchFamily="34" charset="-120"/>
               </a:rPr>
-              <a:t>LinkedIn outreach to ministry leaders</a:t>
+              <a:t>Facebook, YouTube and LinkedIn aimed at pastors and church staff</a:t>
             </a:r>
             <a:endParaRPr lang="en-US" sz="1250" dirty="0"/>
           </a:p>
@@ -14351,7 +14351,7 @@
                 <a:ea typeface="Calibri" pitchFamily="34" charset="-122"/>
                 <a:cs typeface="Calibri" pitchFamily="34" charset="-120"/>
               </a:rPr>
-              <a:t>LinkedIn and short videos showing live AI role-plays</a:t>
+              <a:t>Cold email to sales reps and sales managers, starting now</a:t>
             </a:r>
             <a:endParaRPr lang="en-US" sz="1250" dirty="0"/>
           </a:p>
@@ -14372,7 +14372,7 @@
                 <a:ea typeface="Calibri" pitchFamily="34" charset="-122"/>
                 <a:cs typeface="Calibri" pitchFamily="34" charset="-120"/>
               </a:rPr>
-              <a:t>Direct outreach to sales managers for team plans</a:t>
+              <a:t>LinkedIn and short videos showing live AI role-plays</a:t>
             </a:r>
             <a:endParaRPr lang="en-US" sz="1250" dirty="0"/>
           </a:p>
@@ -14414,7 +14414,7 @@
                 <a:ea typeface="Calibri" pitchFamily="34" charset="-122"/>
                 <a:cs typeface="Calibri" pitchFamily="34" charset="-120"/>
               </a:rPr>
-              <a:t>App store search and referral rewards</a:t>
+              <a:t>Team plans, app store search and referral rewards</a:t>
             </a:r>
             <a:endParaRPr lang="en-US" sz="1250" dirty="0"/>
           </a:p>
@@ -14453,7 +14453,7 @@
                 <a:ea typeface="Calibri" pitchFamily="34" charset="-122"/>
                 <a:cs typeface="Calibri" pitchFamily="34" charset="-120"/>
               </a:rPr>
-              <a:t>Powered by AppForge's marketing tools: cold emails, social posts, ads and presentations for every app.</a:t>
+              <a:t>Cold email first, to win paying customers fast: AppForge writes the campaigns, plus social posts, ads and presentations.</a:t>
             </a:r>
             <a:endParaRPr lang="en-US" sz="1250" dirty="0"/>
           </a:p>
@@ -17075,7 +17075,7 @@
                 <a:ea typeface="Calibri" pitchFamily="34" charset="-122"/>
                 <a:cs typeface="Calibri" pitchFamily="34" charset="-120"/>
               </a:rPr>
-              <a:t>Marketing and outreach for all apps</a:t>
+              <a:t>Marketing: cold email, ads and outreach</a:t>
             </a:r>
             <a:endParaRPr lang="en-US" sz="1350" dirty="0"/>
           </a:p>
@@ -17943,7 +17943,7 @@
                 <a:ea typeface="Calibri" pitchFamily="34" charset="-122"/>
                 <a:cs typeface="Calibri" pitchFamily="34" charset="-120"/>
               </a:rPr>
-              <a:t>Turn trials into paying users; test ads; add group plans</a:t>
+              <a:t>Launch cold email; turn trials into paying users; test ads</a:t>
             </a:r>
             <a:endParaRPr lang="en-US" sz="1250" dirty="0"/>
           </a:p>

</xml_diff>

<commit_message>
Capitalize contact email; make founder cell number an optional build input
The public deck shows the office phone only. A copy with the cell number
can be built locally with CELL_PHONE=... so it stays out of this public
repository.

Co-Authored-By: Claude Opus 5.5 <noreply@anthropic.com>
Claude-Session: https://claude.ai/code/session_01Kb7k1mwMTUZRFKd9bWckpj
</commit_message>
<xml_diff>
--- a/pitch-deck/Cedarworks-Apps-Pitch-Deck.pptx
+++ b/pitch-deck/Cedarworks-Apps-Pitch-Deck.pptx
@@ -4009,8 +4009,8 @@
         </p:nvSpPr>
         <p:spPr>
           <a:xfrm>
-            <a:off x="457200" y="4206240"/>
-            <a:ext cx="8229600" cy="274320"/>
+            <a:off x="457200" y="4069080"/>
+            <a:ext cx="8229600" cy="502920"/>
           </a:xfrm>
           <a:prstGeom prst="rect">
             <a:avLst/>
@@ -4023,6 +4023,9 @@
           <a:lstStyle/>
           <a:p>
             <a:pPr indent="0" marL="0">
+              <a:lnSpc>
+                <a:spcPct val="115000"/>
+              </a:lnSpc>
               <a:buNone/>
             </a:pPr>
             <a:r>
@@ -4034,7 +4037,27 @@
                 <a:ea typeface="Calibri" pitchFamily="34" charset="-122"/>
                 <a:cs typeface="Calibri" pitchFamily="34" charset="-120"/>
               </a:rPr>
-              <a:t>James Chambers, Founder  ·  james@cedarworksapps.com  ·  417-370-2084  ·  cedarworksapps.com</a:t>
+              <a:t>James Chambers, Founder  ·  James@cedarworksapps.com  ·  cedarworksapps.com</a:t>
+            </a:r>
+            <a:endParaRPr lang="en-US" sz="1200" dirty="0"/>
+          </a:p>
+          <a:p>
+            <a:pPr indent="0" marL="0">
+              <a:lnSpc>
+                <a:spcPct val="115000"/>
+              </a:lnSpc>
+              <a:buNone/>
+            </a:pPr>
+            <a:r>
+              <a:rPr lang="en-US" sz="1200" dirty="0">
+                <a:solidFill>
+                  <a:srgbClr val="F4EBD5"/>
+                </a:solidFill>
+                <a:latin typeface="Calibri" pitchFamily="34" charset="0"/>
+                <a:ea typeface="Calibri" pitchFamily="34" charset="-122"/>
+                <a:cs typeface="Calibri" pitchFamily="34" charset="-120"/>
+              </a:rPr>
+              <a:t>Office 417-370-2084</a:t>
             </a:r>
             <a:endParaRPr lang="en-US" sz="1200" dirty="0"/>
           </a:p>
@@ -14174,7 +14197,7 @@
         </p:blipFill>
         <p:spPr>
           <a:xfrm>
-            <a:off x="6172200" y="2423160"/>
+            <a:off x="6172200" y="2331720"/>
             <a:ext cx="237744" cy="237744"/>
           </a:xfrm>
           <a:prstGeom prst="rect">
@@ -14190,7 +14213,7 @@
         </p:nvSpPr>
         <p:spPr>
           <a:xfrm>
-            <a:off x="6510528" y="2377440"/>
+            <a:off x="6510528" y="2286000"/>
             <a:ext cx="2103120" cy="329184"/>
           </a:xfrm>
           <a:prstGeom prst="rect">
@@ -14215,7 +14238,7 @@
                 <a:ea typeface="Calibri" pitchFamily="34" charset="-122"/>
                 <a:cs typeface="Calibri" pitchFamily="34" charset="-120"/>
               </a:rPr>
-              <a:t>james@cedarworksapps.com</a:t>
+              <a:t>James@cedarworksapps.com</a:t>
             </a:r>
             <a:endParaRPr lang="en-US" sz="1200" dirty="0"/>
           </a:p>
@@ -14237,7 +14260,7 @@
         </p:blipFill>
         <p:spPr>
           <a:xfrm>
-            <a:off x="6172200" y="2880360"/>
+            <a:off x="6172200" y="2724912"/>
             <a:ext cx="237744" cy="237744"/>
           </a:xfrm>
           <a:prstGeom prst="rect">
@@ -14253,7 +14276,7 @@
         </p:nvSpPr>
         <p:spPr>
           <a:xfrm>
-            <a:off x="6510528" y="2834640"/>
+            <a:off x="6510528" y="2679192"/>
             <a:ext cx="2103120" cy="329184"/>
           </a:xfrm>
           <a:prstGeom prst="rect">
@@ -14278,7 +14301,7 @@
                 <a:ea typeface="Calibri" pitchFamily="34" charset="-122"/>
                 <a:cs typeface="Calibri" pitchFamily="34" charset="-120"/>
               </a:rPr>
-              <a:t>417-370-2084</a:t>
+              <a:t>Office 417-370-2084</a:t>
             </a:r>
             <a:endParaRPr lang="en-US" sz="1200" dirty="0"/>
           </a:p>
@@ -14300,7 +14323,7 @@
         </p:blipFill>
         <p:spPr>
           <a:xfrm>
-            <a:off x="6172200" y="3337560"/>
+            <a:off x="6172200" y="3118104"/>
             <a:ext cx="237744" cy="237744"/>
           </a:xfrm>
           <a:prstGeom prst="rect">
@@ -14316,7 +14339,7 @@
         </p:nvSpPr>
         <p:spPr>
           <a:xfrm>
-            <a:off x="6510528" y="3291840"/>
+            <a:off x="6510528" y="3072384"/>
             <a:ext cx="2103120" cy="329184"/>
           </a:xfrm>
           <a:prstGeom prst="rect">
@@ -14363,7 +14386,7 @@
         </p:blipFill>
         <p:spPr>
           <a:xfrm>
-            <a:off x="6172200" y="3794760"/>
+            <a:off x="6172200" y="3511296"/>
             <a:ext cx="237744" cy="237744"/>
           </a:xfrm>
           <a:prstGeom prst="rect">
@@ -14379,7 +14402,7 @@
         </p:nvSpPr>
         <p:spPr>
           <a:xfrm>
-            <a:off x="6510528" y="3749040"/>
+            <a:off x="6510528" y="3465576"/>
             <a:ext cx="2103120" cy="329184"/>
           </a:xfrm>
           <a:prstGeom prst="rect">

</xml_diff>

<commit_message>
Update trial user counts: PastorAI 31 (+1 UK test user), Ready Room 36 (+1 U.S. test user)
Co-Authored-By: Claude Opus 5.5 <noreply@anthropic.com>
Claude-Session: https://claude.ai/code/session_01Kb7k1mwMTUZRFKd9bWckpj
</commit_message>
<xml_diff>
--- a/pitch-deck/Cedarworks-Apps-Pitch-Deck.pptx
+++ b/pitch-deck/Cedarworks-Apps-Pitch-Deck.pptx
@@ -2993,7 +2993,7 @@
           <a:p>
             <a:r>
               <a:rPr lang="en-US" dirty="0"/>
-              <a:t>PastorAI puts the tools that fill a pastor's week in one place: sermons, series planning, Bible studies, social media, devotionals, children's lessons, translation into 10 languages and sermon rehearsal. It's live on iOS, Android and the web at $47 a month after a 14-day free trial, with about 15 trial users. One of them, Pastor Dennis, told us: 'This will save me so much time. It's a great tool.'</a:t>
+              <a:t>PastorAI puts the tools that fill a pastor's week in one place: sermons, series planning, Bible studies, social media, devotionals, children's lessons, translation into 10 languages and sermon rehearsal. It's live on iOS, Android and the web at $47 a month after a 14-day free trial, with 31 trial users and a test user in the UK. One of them, Pastor Dennis, told us: 'This will save me so much time. It's a great tool.'</a:t>
             </a:r>
             <a:endParaRPr lang="en-US" dirty="0"/>
           </a:p>
@@ -3081,7 +3081,7 @@
           <a:p>
             <a:r>
               <a:rPr lang="en-US" dirty="0"/>
-              <a:t>Ready Room lets sales reps rehearse on an AI prospect that talks back out loud. Reps choose a drill, a difficulty and a prospect from 18+ industries, then get graded by an AI coach. They can also upload their real calls for the same scorecard. It's $29 a month or $249 a year, live on iOS, Android and the web, with about 15 trial users. It's built on what I learned in 40 years of selling.</a:t>
+              <a:t>Ready Room lets sales reps rehearse on an AI prospect that talks back out loud. Reps choose a drill, a difficulty and a prospect from 18+ industries, then get graded by an AI coach. They can also upload their real calls for the same scorecard. It's $29 a month or $249 a year, live on iOS, Android and the web, with 36 trial users and a test user in the U.S. It's built on what I learned in 40 years of selling.</a:t>
             </a:r>
             <a:endParaRPr lang="en-US" dirty="0"/>
           </a:p>
@@ -3257,7 +3257,7 @@
           <a:p>
             <a:r>
               <a:rPr lang="en-US" dirty="0"/>
-              <a:t>We're honest about where we are: the products are built, live on three platforms, with subscriptions and free trials working, and about 30 people on trials. We don't have paying customers yet. Proving people will pay is the first job of this round: in the next 90 days we're aiming for 75 paying subscribers, about $2,850 a month in revenue, at least 20% of trials converting and fewer than 6% of subscribers cancelling each month. We'll report these to investors monthly.</a:t>
+              <a:t>We're honest about where we are: the products are built, live on three platforms, with subscriptions and free trials working, and 67 people on free trials (31 on PastorAI and 36 on Ready Room), plus test users in the UK and the U.S. We don't have paying customers yet. Proving people will pay is the first job of this round: in the next 90 days we're aiming for 75 paying subscribers, about $2,850 a month in revenue, at least 20% of trials converting and fewer than 6% of subscribers cancelling each month. We'll report these to investors monthly.</a:t>
             </a:r>
             <a:endParaRPr lang="en-US" dirty="0"/>
           </a:p>
@@ -26985,7 +26985,7 @@
                 <a:ea typeface="Cambria" pitchFamily="34" charset="-122"/>
                 <a:cs typeface="Cambria" pitchFamily="34" charset="-120"/>
               </a:rPr>
-              <a:t>~15</a:t>
+              <a:t>31</a:t>
             </a:r>
             <a:endParaRPr lang="en-US" sz="2600" dirty="0"/>
           </a:p>
@@ -27024,7 +27024,7 @@
                 <a:ea typeface="Calibri" pitchFamily="34" charset="-122"/>
                 <a:cs typeface="Calibri" pitchFamily="34" charset="-120"/>
               </a:rPr>
-              <a:t>trial users so far</a:t>
+              <a:t>trial users, plus 1 test user in the UK</a:t>
             </a:r>
             <a:endParaRPr lang="en-US" sz="1200" dirty="0"/>
           </a:p>
@@ -27509,7 +27509,7 @@
                 <a:ea typeface="Cambria" pitchFamily="34" charset="-122"/>
                 <a:cs typeface="Cambria" pitchFamily="34" charset="-120"/>
               </a:rPr>
-              <a:t>~15</a:t>
+              <a:t>36</a:t>
             </a:r>
             <a:endParaRPr lang="en-US" sz="2600" dirty="0"/>
           </a:p>
@@ -27548,7 +27548,7 @@
                 <a:ea typeface="Calibri" pitchFamily="34" charset="-122"/>
                 <a:cs typeface="Calibri" pitchFamily="34" charset="-120"/>
               </a:rPr>
-              <a:t>trial users so far</a:t>
+              <a:t>trial users, plus 1 test user in the U.S.</a:t>
             </a:r>
             <a:endParaRPr lang="en-US" sz="1200" dirty="0"/>
           </a:p>
@@ -29623,7 +29623,7 @@
                 <a:ea typeface="Cambria" pitchFamily="34" charset="-122"/>
                 <a:cs typeface="Cambria" pitchFamily="34" charset="-120"/>
               </a:rPr>
-              <a:t>~30</a:t>
+              <a:t>67</a:t>
             </a:r>
             <a:endParaRPr lang="en-US" sz="3000" dirty="0"/>
           </a:p>
@@ -29662,7 +29662,7 @@
                 <a:ea typeface="Calibri" pitchFamily="34" charset="-122"/>
                 <a:cs typeface="Calibri" pitchFamily="34" charset="-120"/>
               </a:rPr>
-              <a:t>trial users across both apps</a:t>
+              <a:t>trial users, plus 2 test users (UK and U.S.)</a:t>
             </a:r>
             <a:endParaRPr lang="en-US" sz="1200" dirty="0"/>
           </a:p>

</xml_diff>